<commit_message>
feat: add ACM logo and Null Pointers team members to PPTX
</commit_message>
<xml_diff>
--- a/public/Kavach_AI_Hackathon_Pitch_Deck.pptx
+++ b/public/Kavach_AI_Hackathon_Pitch_Deck.pptx
@@ -1498,16 +1498,40 @@
           <a:chExt cx="0" cy="0"/>
         </a:xfrm>
       </p:grpSpPr>
-      <p:sp>
-        <p:nvSpPr>
-          <p:cNvPr id="2" name="Text 0"/>
-          <p:cNvSpPr/>
-          <p:nvPr/>
-        </p:nvSpPr>
-        <p:spPr>
-          <a:xfrm>
-            <a:off x="731520" y="548640"/>
-            <a:ext cx="7315200" cy="320040"/>
+      <p:pic>
+        <p:nvPicPr>
+          <p:cNvPr id="2" name="Image 0" descr="D:\hackathon_elicit_acm\public\acm-logo.png">    </p:cNvPr>
+          <p:cNvPicPr>
+            <a:picLocks noChangeAspect="1"/>
+          </p:cNvPicPr>
+          <p:nvPr/>
+        </p:nvPicPr>
+        <p:blipFill>
+          <a:blip r:embed="rId1"/>
+          <a:stretch>
+            <a:fillRect/>
+          </a:stretch>
+        </p:blipFill>
+        <p:spPr>
+          <a:xfrm>
+            <a:off x="731520" y="320040"/>
+            <a:ext cx="411480" cy="411480"/>
+          </a:xfrm>
+          <a:prstGeom prst="rect">
+            <a:avLst/>
+          </a:prstGeom>
+        </p:spPr>
+      </p:pic>
+      <p:sp>
+        <p:nvSpPr>
+          <p:cNvPr id="3" name="Text 0"/>
+          <p:cNvSpPr/>
+          <p:nvPr/>
+        </p:nvSpPr>
+        <p:spPr>
+          <a:xfrm>
+            <a:off x="1280160" y="411480"/>
+            <a:ext cx="8229600" cy="320040"/>
           </a:xfrm>
           <a:prstGeom prst="rect">
             <a:avLst/>
@@ -1523,7 +1547,7 @@
               <a:buNone/>
             </a:pPr>
             <a:r>
-              <a:rPr lang="en-US" sz="1000" b="1" dirty="0">
+              <a:rPr lang="en-US" sz="1050" b="1" dirty="0">
                 <a:solidFill>
                   <a:srgbClr val="38BDF8"/>
                 </a:solidFill>
@@ -1531,22 +1555,22 @@
                 <a:ea typeface="Consolas" pitchFamily="34" charset="-122"/>
                 <a:cs typeface="Consolas" pitchFamily="34" charset="-120"/>
               </a:rPr>
-              <a:t>⚡ ELICIT ACM HACKATHON • NATIONAL CYBERSECURITY TRACK</a:t>
-            </a:r>
-            <a:endParaRPr lang="en-US" sz="1000" dirty="0"/>
-          </a:p>
-        </p:txBody>
-      </p:sp>
-      <p:sp>
-        <p:nvSpPr>
-          <p:cNvPr id="3" name="Text 1"/>
-          <p:cNvSpPr/>
-          <p:nvPr/>
-        </p:nvSpPr>
-        <p:spPr>
-          <a:xfrm>
-            <a:off x="731520" y="960120"/>
-            <a:ext cx="10515600" cy="1097280"/>
+              <a:t>⚡ ELICIT ACM HACKATHON • TEAM: NULL POINTERS</a:t>
+            </a:r>
+            <a:endParaRPr lang="en-US" sz="1050" dirty="0"/>
+          </a:p>
+        </p:txBody>
+      </p:sp>
+      <p:sp>
+        <p:nvSpPr>
+          <p:cNvPr id="4" name="Text 1"/>
+          <p:cNvSpPr/>
+          <p:nvPr/>
+        </p:nvSpPr>
+        <p:spPr>
+          <a:xfrm>
+            <a:off x="731520" y="868680"/>
+            <a:ext cx="10515600" cy="1005840"/>
           </a:xfrm>
           <a:prstGeom prst="rect">
             <a:avLst/>
@@ -1562,7 +1586,7 @@
               <a:buNone/>
             </a:pPr>
             <a:r>
-              <a:rPr lang="en-US" sz="2200" b="1" dirty="0">
+              <a:rPr lang="en-US" sz="2000" b="1" dirty="0">
                 <a:solidFill>
                   <a:srgbClr val="F8FAFC"/>
                 </a:solidFill>
@@ -1572,24 +1596,24 @@
               </a:rPr>
               <a:t>Over ₹1,750+ Crore Lost to SMS Fraud in India — Because 80% of Scam Texts Dodge Firewalls by Writing Hindi in English Letters.</a:t>
             </a:r>
-            <a:endParaRPr lang="en-US" sz="2200" dirty="0"/>
-          </a:p>
-        </p:txBody>
-      </p:sp>
-      <p:sp>
-        <p:nvSpPr>
-          <p:cNvPr id="4" name="Shape 2"/>
-          <p:cNvSpPr/>
-          <p:nvPr/>
-        </p:nvSpPr>
-        <p:spPr>
-          <a:xfrm>
-            <a:off x="731520" y="2194560"/>
-            <a:ext cx="10698480" cy="1645920"/>
+            <a:endParaRPr lang="en-US" sz="2000" dirty="0"/>
+          </a:p>
+        </p:txBody>
+      </p:sp>
+      <p:sp>
+        <p:nvSpPr>
+          <p:cNvPr id="5" name="Shape 2"/>
+          <p:cNvSpPr/>
+          <p:nvPr/>
+        </p:nvSpPr>
+        <p:spPr>
+          <a:xfrm>
+            <a:off x="731520" y="1965960"/>
+            <a:ext cx="10698480" cy="1554480"/>
           </a:xfrm>
           <a:prstGeom prst="rect">
             <a:avLst>
-              <a:gd name="adj" fmla="val 5556"/>
+              <a:gd name="adj" fmla="val 5882"/>
             </a:avLst>
           </a:prstGeom>
           <a:solidFill>
@@ -1605,14 +1629,14 @@
       </p:sp>
       <p:sp>
         <p:nvSpPr>
-          <p:cNvPr id="5" name="Text 3"/>
-          <p:cNvSpPr/>
-          <p:nvPr/>
-        </p:nvSpPr>
-        <p:spPr>
-          <a:xfrm>
-            <a:off x="1005840" y="2377440"/>
-            <a:ext cx="5486400" cy="365760"/>
+          <p:cNvPr id="6" name="Text 3"/>
+          <p:cNvSpPr/>
+          <p:nvPr/>
+        </p:nvSpPr>
+        <p:spPr>
+          <a:xfrm>
+            <a:off x="1005840" y="2103120"/>
+            <a:ext cx="7315200" cy="320040"/>
           </a:xfrm>
           <a:prstGeom prst="rect">
             <a:avLst/>
@@ -1628,7 +1652,7 @@
               <a:buNone/>
             </a:pPr>
             <a:r>
-              <a:rPr lang="en-US" sz="1800" b="1" dirty="0">
+              <a:rPr lang="en-US" sz="1600" b="1" dirty="0">
                 <a:solidFill>
                   <a:srgbClr val="38BDF8"/>
                 </a:solidFill>
@@ -1636,21 +1660,21 @@
                 <a:ea typeface="Arial" pitchFamily="34" charset="-122"/>
                 <a:cs typeface="Arial" pitchFamily="34" charset="-120"/>
               </a:rPr>
-              <a:t>🛡️ KAVACH AI (कवच)</a:t>
-            </a:r>
-            <a:endParaRPr lang="en-US" sz="1800" dirty="0"/>
-          </a:p>
-        </p:txBody>
-      </p:sp>
-      <p:sp>
-        <p:nvSpPr>
-          <p:cNvPr id="6" name="Text 4"/>
-          <p:cNvSpPr/>
-          <p:nvPr/>
-        </p:nvSpPr>
-        <p:spPr>
-          <a:xfrm>
-            <a:off x="1005840" y="2788920"/>
+              <a:t>🛡️ KAVACH AI (कवच) — Team: Null Pointers</a:t>
+            </a:r>
+            <a:endParaRPr lang="en-US" sz="1600" dirty="0"/>
+          </a:p>
+        </p:txBody>
+      </p:sp>
+      <p:sp>
+        <p:nvSpPr>
+          <p:cNvPr id="7" name="Text 4"/>
+          <p:cNvSpPr/>
+          <p:nvPr/>
+        </p:nvSpPr>
+        <p:spPr>
+          <a:xfrm>
+            <a:off x="1005840" y="2468880"/>
             <a:ext cx="10058400" cy="868680"/>
           </a:xfrm>
           <a:prstGeom prst="rect">
@@ -1667,7 +1691,7 @@
               <a:buNone/>
             </a:pPr>
             <a:r>
-              <a:rPr lang="en-US" sz="1200" dirty="0">
+              <a:rPr lang="en-US" sz="1100" dirty="0">
                 <a:solidFill>
                   <a:srgbClr val="94A3B8"/>
                 </a:solidFill>
@@ -1677,14 +1701,14 @@
               </a:rPr>
               <a:t>India’s First Real-Time Dual-Engine Vernacular SMS Phishing Defense Shield.</a:t>
             </a:r>
-            <a:endParaRPr lang="en-US" sz="1200" dirty="0"/>
-          </a:p>
-          <a:p>
-            <a:pPr indent="0" marL="0">
-              <a:buNone/>
-            </a:pPr>
-            <a:r>
-              <a:rPr lang="en-US" sz="1200" dirty="0">
+            <a:endParaRPr lang="en-US" sz="1100" dirty="0"/>
+          </a:p>
+          <a:p>
+            <a:pPr indent="0" marL="0">
+              <a:buNone/>
+            </a:pPr>
+            <a:r>
+              <a:rPr lang="en-US" sz="1100" dirty="0">
                 <a:solidFill>
                   <a:srgbClr val="94A3B8"/>
                 </a:solidFill>
@@ -1694,24 +1718,24 @@
               </a:rPr>
               <a:t>Deobfuscates Latin-script regional dialects (Hinglish, Tanglish, Benglish) and adversarial leetspeak in &lt;45ms by blending deterministic Levenshtein heuristics (40%) with multi-model Google Gemini Flash AI (60%).</a:t>
             </a:r>
-            <a:endParaRPr lang="en-US" sz="1200" dirty="0"/>
-          </a:p>
-        </p:txBody>
-      </p:sp>
-      <p:sp>
-        <p:nvSpPr>
-          <p:cNvPr id="7" name="Shape 5"/>
-          <p:cNvSpPr/>
-          <p:nvPr/>
-        </p:nvSpPr>
-        <p:spPr>
-          <a:xfrm>
-            <a:off x="731520" y="4114800"/>
-            <a:ext cx="3383280" cy="1737360"/>
+            <a:endParaRPr lang="en-US" sz="1100" dirty="0"/>
+          </a:p>
+        </p:txBody>
+      </p:sp>
+      <p:sp>
+        <p:nvSpPr>
+          <p:cNvPr id="8" name="Shape 5"/>
+          <p:cNvSpPr/>
+          <p:nvPr/>
+        </p:nvSpPr>
+        <p:spPr>
+          <a:xfrm>
+            <a:off x="731520" y="3657600"/>
+            <a:ext cx="2606040" cy="2468880"/>
           </a:xfrm>
           <a:prstGeom prst="rect">
             <a:avLst>
-              <a:gd name="adj" fmla="val 5263"/>
+              <a:gd name="adj" fmla="val 3704"/>
             </a:avLst>
           </a:prstGeom>
           <a:solidFill>
@@ -1727,14 +1751,14 @@
       </p:sp>
       <p:sp>
         <p:nvSpPr>
-          <p:cNvPr id="8" name="Text 6"/>
-          <p:cNvSpPr/>
-          <p:nvPr/>
-        </p:nvSpPr>
-        <p:spPr>
-          <a:xfrm>
-            <a:off x="914400" y="4297680"/>
-            <a:ext cx="3017520" cy="274320"/>
+          <p:cNvPr id="9" name="Text 6"/>
+          <p:cNvSpPr/>
+          <p:nvPr/>
+        </p:nvSpPr>
+        <p:spPr>
+          <a:xfrm>
+            <a:off x="868680" y="3794760"/>
+            <a:ext cx="2331720" cy="594360"/>
           </a:xfrm>
           <a:prstGeom prst="rect">
             <a:avLst/>
@@ -1750,7 +1774,7 @@
               <a:buNone/>
             </a:pPr>
             <a:r>
-              <a:rPr lang="en-US" sz="1300" b="1" dirty="0">
+              <a:rPr lang="en-US" sz="1050" b="1" dirty="0">
                 <a:solidFill>
                   <a:srgbClr val="F8FAFC"/>
                 </a:solidFill>
@@ -1758,22 +1782,22 @@
                 <a:ea typeface="Arial" pitchFamily="34" charset="-122"/>
                 <a:cs typeface="Arial" pitchFamily="34" charset="-120"/>
               </a:rPr>
-              <a:t>👤 Bharath &amp; Team</a:t>
-            </a:r>
-            <a:endParaRPr lang="en-US" sz="1300" dirty="0"/>
-          </a:p>
-        </p:txBody>
-      </p:sp>
-      <p:sp>
-        <p:nvSpPr>
-          <p:cNvPr id="9" name="Text 7"/>
-          <p:cNvSpPr/>
-          <p:nvPr/>
-        </p:nvSpPr>
-        <p:spPr>
-          <a:xfrm>
-            <a:off x="914400" y="4617720"/>
-            <a:ext cx="3017520" cy="228600"/>
+              <a:t>👤 Gummadi Bharath Kumar Wesly</a:t>
+            </a:r>
+            <a:endParaRPr lang="en-US" sz="1050" dirty="0"/>
+          </a:p>
+        </p:txBody>
+      </p:sp>
+      <p:sp>
+        <p:nvSpPr>
+          <p:cNvPr id="10" name="Text 7"/>
+          <p:cNvSpPr/>
+          <p:nvPr/>
+        </p:nvSpPr>
+        <p:spPr>
+          <a:xfrm>
+            <a:off x="868680" y="4434840"/>
+            <a:ext cx="2331720" cy="411480"/>
           </a:xfrm>
           <a:prstGeom prst="rect">
             <a:avLst/>
@@ -1789,7 +1813,7 @@
               <a:buNone/>
             </a:pPr>
             <a:r>
-              <a:rPr lang="en-US" sz="1000" b="1" dirty="0">
+              <a:rPr lang="en-US" sz="900" b="1" dirty="0">
                 <a:solidFill>
                   <a:srgbClr val="C084FC"/>
                 </a:solidFill>
@@ -1797,22 +1821,22 @@
                 <a:ea typeface="Consolas" pitchFamily="34" charset="-122"/>
                 <a:cs typeface="Consolas" pitchFamily="34" charset="-120"/>
               </a:rPr>
-              <a:t>Lead AI &amp; Security Architect</a:t>
-            </a:r>
-            <a:endParaRPr lang="en-US" sz="1000" dirty="0"/>
-          </a:p>
-        </p:txBody>
-      </p:sp>
-      <p:sp>
-        <p:nvSpPr>
-          <p:cNvPr id="10" name="Text 8"/>
-          <p:cNvSpPr/>
-          <p:nvPr/>
-        </p:nvSpPr>
-        <p:spPr>
-          <a:xfrm>
-            <a:off x="914400" y="4937760"/>
-            <a:ext cx="3017520" cy="731520"/>
+              <a:t>Team Leader • AI Architect</a:t>
+            </a:r>
+            <a:endParaRPr lang="en-US" sz="900" dirty="0"/>
+          </a:p>
+        </p:txBody>
+      </p:sp>
+      <p:sp>
+        <p:nvSpPr>
+          <p:cNvPr id="11" name="Text 8"/>
+          <p:cNvSpPr/>
+          <p:nvPr/>
+        </p:nvSpPr>
+        <p:spPr>
+          <a:xfrm>
+            <a:off x="868680" y="4892040"/>
+            <a:ext cx="2331720" cy="1005840"/>
           </a:xfrm>
           <a:prstGeom prst="rect">
             <a:avLst/>
@@ -1828,7 +1852,7 @@
               <a:buNone/>
             </a:pPr>
             <a:r>
-              <a:rPr lang="en-US" sz="1000" dirty="0">
+              <a:rPr lang="en-US" sz="950" dirty="0">
                 <a:solidFill>
                   <a:srgbClr val="94A3B8"/>
                 </a:solidFill>
@@ -1836,26 +1860,26 @@
                 <a:ea typeface="Calibri" pitchFamily="34" charset="-122"/>
                 <a:cs typeface="Calibri" pitchFamily="34" charset="-120"/>
               </a:rPr>
-              <a:t>Threat Modeling, Indic NLP &amp; Multi-Model Cascade</a:t>
-            </a:r>
-            <a:endParaRPr lang="en-US" sz="1000" dirty="0"/>
-          </a:p>
-        </p:txBody>
-      </p:sp>
-      <p:sp>
-        <p:nvSpPr>
-          <p:cNvPr id="11" name="Shape 9"/>
-          <p:cNvSpPr/>
-          <p:nvPr/>
-        </p:nvSpPr>
-        <p:spPr>
-          <a:xfrm>
-            <a:off x="4389120" y="4114800"/>
-            <a:ext cx="3383280" cy="1737360"/>
+              <a:t>Threat Modeling &amp; Gemini Cascade</a:t>
+            </a:r>
+            <a:endParaRPr lang="en-US" sz="950" dirty="0"/>
+          </a:p>
+        </p:txBody>
+      </p:sp>
+      <p:sp>
+        <p:nvSpPr>
+          <p:cNvPr id="12" name="Shape 9"/>
+          <p:cNvSpPr/>
+          <p:nvPr/>
+        </p:nvSpPr>
+        <p:spPr>
+          <a:xfrm>
+            <a:off x="3429000" y="3657600"/>
+            <a:ext cx="2606040" cy="2468880"/>
           </a:xfrm>
           <a:prstGeom prst="rect">
             <a:avLst>
-              <a:gd name="adj" fmla="val 5263"/>
+              <a:gd name="adj" fmla="val 3704"/>
             </a:avLst>
           </a:prstGeom>
           <a:solidFill>
@@ -1871,14 +1895,14 @@
       </p:sp>
       <p:sp>
         <p:nvSpPr>
-          <p:cNvPr id="12" name="Text 10"/>
-          <p:cNvSpPr/>
-          <p:nvPr/>
-        </p:nvSpPr>
-        <p:spPr>
-          <a:xfrm>
-            <a:off x="4572000" y="4297680"/>
-            <a:ext cx="3017520" cy="274320"/>
+          <p:cNvPr id="13" name="Text 10"/>
+          <p:cNvSpPr/>
+          <p:nvPr/>
+        </p:nvSpPr>
+        <p:spPr>
+          <a:xfrm>
+            <a:off x="3566160" y="3794760"/>
+            <a:ext cx="2331720" cy="594360"/>
           </a:xfrm>
           <a:prstGeom prst="rect">
             <a:avLst/>
@@ -1894,7 +1918,7 @@
               <a:buNone/>
             </a:pPr>
             <a:r>
-              <a:rPr lang="en-US" sz="1300" b="1" dirty="0">
+              <a:rPr lang="en-US" sz="1050" b="1" dirty="0">
                 <a:solidFill>
                   <a:srgbClr val="F8FAFC"/>
                 </a:solidFill>
@@ -1902,22 +1926,22 @@
                 <a:ea typeface="Arial" pitchFamily="34" charset="-122"/>
                 <a:cs typeface="Arial" pitchFamily="34" charset="-120"/>
               </a:rPr>
-              <a:t>👤 Core Engineering</a:t>
-            </a:r>
-            <a:endParaRPr lang="en-US" sz="1300" dirty="0"/>
-          </a:p>
-        </p:txBody>
-      </p:sp>
-      <p:sp>
-        <p:nvSpPr>
-          <p:cNvPr id="13" name="Text 11"/>
-          <p:cNvSpPr/>
-          <p:nvPr/>
-        </p:nvSpPr>
-        <p:spPr>
-          <a:xfrm>
-            <a:off x="4572000" y="4617720"/>
-            <a:ext cx="3017520" cy="228600"/>
+              <a:t>👤 Swarnim Sulekh</a:t>
+            </a:r>
+            <a:endParaRPr lang="en-US" sz="1050" dirty="0"/>
+          </a:p>
+        </p:txBody>
+      </p:sp>
+      <p:sp>
+        <p:nvSpPr>
+          <p:cNvPr id="14" name="Text 11"/>
+          <p:cNvSpPr/>
+          <p:nvPr/>
+        </p:nvSpPr>
+        <p:spPr>
+          <a:xfrm>
+            <a:off x="3566160" y="4434840"/>
+            <a:ext cx="2331720" cy="411480"/>
           </a:xfrm>
           <a:prstGeom prst="rect">
             <a:avLst/>
@@ -1933,7 +1957,7 @@
               <a:buNone/>
             </a:pPr>
             <a:r>
-              <a:rPr lang="en-US" sz="1000" b="1" dirty="0">
+              <a:rPr lang="en-US" sz="900" b="1" dirty="0">
                 <a:solidFill>
                   <a:srgbClr val="C084FC"/>
                 </a:solidFill>
@@ -1941,22 +1965,22 @@
                 <a:ea typeface="Consolas" pitchFamily="34" charset="-122"/>
                 <a:cs typeface="Consolas" pitchFamily="34" charset="-120"/>
               </a:rPr>
-              <a:t>Full-Stack &amp; Systems Engineer</a:t>
-            </a:r>
-            <a:endParaRPr lang="en-US" sz="1000" dirty="0"/>
-          </a:p>
-        </p:txBody>
-      </p:sp>
-      <p:sp>
-        <p:nvSpPr>
-          <p:cNvPr id="14" name="Text 12"/>
-          <p:cNvSpPr/>
-          <p:nvPr/>
-        </p:nvSpPr>
-        <p:spPr>
-          <a:xfrm>
-            <a:off x="4572000" y="4937760"/>
-            <a:ext cx="3017520" cy="731520"/>
+              <a:t>Full-Stack &amp; Backend Engineer</a:t>
+            </a:r>
+            <a:endParaRPr lang="en-US" sz="900" dirty="0"/>
+          </a:p>
+        </p:txBody>
+      </p:sp>
+      <p:sp>
+        <p:nvSpPr>
+          <p:cNvPr id="15" name="Text 12"/>
+          <p:cNvSpPr/>
+          <p:nvPr/>
+        </p:nvSpPr>
+        <p:spPr>
+          <a:xfrm>
+            <a:off x="3566160" y="4892040"/>
+            <a:ext cx="2331720" cy="1005840"/>
           </a:xfrm>
           <a:prstGeom prst="rect">
             <a:avLst/>
@@ -1972,7 +1996,7 @@
               <a:buNone/>
             </a:pPr>
             <a:r>
-              <a:rPr lang="en-US" sz="1000" dirty="0">
+              <a:rPr lang="en-US" sz="950" dirty="0">
                 <a:solidFill>
                   <a:srgbClr val="94A3B8"/>
                 </a:solidFill>
@@ -1980,26 +2004,26 @@
                 <a:ea typeface="Calibri" pitchFamily="34" charset="-122"/>
                 <a:cs typeface="Calibri" pitchFamily="34" charset="-120"/>
               </a:rPr>
-              <a:t>Low-Latency Serverless, Edge PWA &amp; Turso DB</a:t>
-            </a:r>
-            <a:endParaRPr lang="en-US" sz="1000" dirty="0"/>
-          </a:p>
-        </p:txBody>
-      </p:sp>
-      <p:sp>
-        <p:nvSpPr>
-          <p:cNvPr id="15" name="Shape 13"/>
-          <p:cNvSpPr/>
-          <p:nvPr/>
-        </p:nvSpPr>
-        <p:spPr>
-          <a:xfrm>
-            <a:off x="8046720" y="4114800"/>
-            <a:ext cx="3383280" cy="1737360"/>
+              <a:t>Serverless APIs &amp; Turso Cloud DB</a:t>
+            </a:r>
+            <a:endParaRPr lang="en-US" sz="950" dirty="0"/>
+          </a:p>
+        </p:txBody>
+      </p:sp>
+      <p:sp>
+        <p:nvSpPr>
+          <p:cNvPr id="16" name="Shape 13"/>
+          <p:cNvSpPr/>
+          <p:nvPr/>
+        </p:nvSpPr>
+        <p:spPr>
+          <a:xfrm>
+            <a:off x="6126480" y="3657600"/>
+            <a:ext cx="2606040" cy="2468880"/>
           </a:xfrm>
           <a:prstGeom prst="rect">
             <a:avLst>
-              <a:gd name="adj" fmla="val 5263"/>
+              <a:gd name="adj" fmla="val 3704"/>
             </a:avLst>
           </a:prstGeom>
           <a:solidFill>
@@ -2015,14 +2039,14 @@
       </p:sp>
       <p:sp>
         <p:nvSpPr>
-          <p:cNvPr id="16" name="Text 14"/>
-          <p:cNvSpPr/>
-          <p:nvPr/>
-        </p:nvSpPr>
-        <p:spPr>
-          <a:xfrm>
-            <a:off x="8229600" y="4297680"/>
-            <a:ext cx="3017520" cy="274320"/>
+          <p:cNvPr id="17" name="Text 14"/>
+          <p:cNvSpPr/>
+          <p:nvPr/>
+        </p:nvSpPr>
+        <p:spPr>
+          <a:xfrm>
+            <a:off x="6263640" y="3794760"/>
+            <a:ext cx="2331720" cy="594360"/>
           </a:xfrm>
           <a:prstGeom prst="rect">
             <a:avLst/>
@@ -2038,7 +2062,7 @@
               <a:buNone/>
             </a:pPr>
             <a:r>
-              <a:rPr lang="en-US" sz="1300" b="1" dirty="0">
+              <a:rPr lang="en-US" sz="1050" b="1" dirty="0">
                 <a:solidFill>
                   <a:srgbClr val="F8FAFC"/>
                 </a:solidFill>
@@ -2046,22 +2070,22 @@
                 <a:ea typeface="Arial" pitchFamily="34" charset="-122"/>
                 <a:cs typeface="Arial" pitchFamily="34" charset="-120"/>
               </a:rPr>
-              <a:t>👤 Linguistic Research</a:t>
-            </a:r>
-            <a:endParaRPr lang="en-US" sz="1300" dirty="0"/>
-          </a:p>
-        </p:txBody>
-      </p:sp>
-      <p:sp>
-        <p:nvSpPr>
-          <p:cNvPr id="17" name="Text 15"/>
-          <p:cNvSpPr/>
-          <p:nvPr/>
-        </p:nvSpPr>
-        <p:spPr>
-          <a:xfrm>
-            <a:off x="8229600" y="4617720"/>
-            <a:ext cx="3017520" cy="228600"/>
+              <a:t>👤 Krrish</a:t>
+            </a:r>
+            <a:endParaRPr lang="en-US" sz="1050" dirty="0"/>
+          </a:p>
+        </p:txBody>
+      </p:sp>
+      <p:sp>
+        <p:nvSpPr>
+          <p:cNvPr id="18" name="Text 15"/>
+          <p:cNvSpPr/>
+          <p:nvPr/>
+        </p:nvSpPr>
+        <p:spPr>
+          <a:xfrm>
+            <a:off x="6263640" y="4434840"/>
+            <a:ext cx="2331720" cy="411480"/>
           </a:xfrm>
           <a:prstGeom prst="rect">
             <a:avLst/>
@@ -2077,7 +2101,7 @@
               <a:buNone/>
             </a:pPr>
             <a:r>
-              <a:rPr lang="en-US" sz="1000" b="1" dirty="0">
+              <a:rPr lang="en-US" sz="900" b="1" dirty="0">
                 <a:solidFill>
                   <a:srgbClr val="C084FC"/>
                 </a:solidFill>
@@ -2085,22 +2109,22 @@
                 <a:ea typeface="Consolas" pitchFamily="34" charset="-122"/>
                 <a:cs typeface="Consolas" pitchFamily="34" charset="-120"/>
               </a:rPr>
-              <a:t>Data &amp; Phonetics Lead</a:t>
-            </a:r>
-            <a:endParaRPr lang="en-US" sz="1000" dirty="0"/>
-          </a:p>
-        </p:txBody>
-      </p:sp>
-      <p:sp>
-        <p:nvSpPr>
-          <p:cNvPr id="18" name="Text 16"/>
-          <p:cNvSpPr/>
-          <p:nvPr/>
-        </p:nvSpPr>
-        <p:spPr>
-          <a:xfrm>
-            <a:off x="8229600" y="4937760"/>
-            <a:ext cx="3017520" cy="731520"/>
+              <a:t>Frontend &amp; PWA Developer</a:t>
+            </a:r>
+            <a:endParaRPr lang="en-US" sz="900" dirty="0"/>
+          </a:p>
+        </p:txBody>
+      </p:sp>
+      <p:sp>
+        <p:nvSpPr>
+          <p:cNvPr id="19" name="Text 16"/>
+          <p:cNvSpPr/>
+          <p:nvPr/>
+        </p:nvSpPr>
+        <p:spPr>
+          <a:xfrm>
+            <a:off x="6263640" y="4892040"/>
+            <a:ext cx="2331720" cy="1005840"/>
           </a:xfrm>
           <a:prstGeom prst="rect">
             <a:avLst/>
@@ -2116,7 +2140,7 @@
               <a:buNone/>
             </a:pPr>
             <a:r>
-              <a:rPr lang="en-US" sz="1000" dirty="0">
+              <a:rPr lang="en-US" sz="950" dirty="0">
                 <a:solidFill>
                   <a:srgbClr val="94A3B8"/>
                 </a:solidFill>
@@ -2124,9 +2148,153 @@
                 <a:ea typeface="Calibri" pitchFamily="34" charset="-122"/>
                 <a:cs typeface="Calibri" pitchFamily="34" charset="-120"/>
               </a:rPr>
-              <a:t>Vernacular Dialect Lexicon &amp; Adversarial Mutation Analysis</a:t>
-            </a:r>
-            <a:endParaRPr lang="en-US" sz="1000" dirty="0"/>
+              <a:t>Editorial UI &amp; Service Worker</a:t>
+            </a:r>
+            <a:endParaRPr lang="en-US" sz="950" dirty="0"/>
+          </a:p>
+        </p:txBody>
+      </p:sp>
+      <p:sp>
+        <p:nvSpPr>
+          <p:cNvPr id="20" name="Shape 17"/>
+          <p:cNvSpPr/>
+          <p:nvPr/>
+        </p:nvSpPr>
+        <p:spPr>
+          <a:xfrm>
+            <a:off x="8823960" y="3657600"/>
+            <a:ext cx="2606040" cy="2468880"/>
+          </a:xfrm>
+          <a:prstGeom prst="rect">
+            <a:avLst>
+              <a:gd name="adj" fmla="val 3704"/>
+            </a:avLst>
+          </a:prstGeom>
+          <a:solidFill>
+            <a:srgbClr val="121218"/>
+          </a:solidFill>
+          <a:ln w="12700">
+            <a:solidFill>
+              <a:srgbClr val="232330"/>
+            </a:solidFill>
+            <a:prstDash val="solid"/>
+          </a:ln>
+        </p:spPr>
+      </p:sp>
+      <p:sp>
+        <p:nvSpPr>
+          <p:cNvPr id="21" name="Text 18"/>
+          <p:cNvSpPr/>
+          <p:nvPr/>
+        </p:nvSpPr>
+        <p:spPr>
+          <a:xfrm>
+            <a:off x="8961120" y="3794760"/>
+            <a:ext cx="2331720" cy="594360"/>
+          </a:xfrm>
+          <a:prstGeom prst="rect">
+            <a:avLst/>
+          </a:prstGeom>
+          <a:noFill/>
+          <a:ln/>
+        </p:spPr>
+        <p:txBody>
+          <a:bodyPr wrap="square" rtlCol="0" anchor="ctr"/>
+          <a:lstStyle/>
+          <a:p>
+            <a:pPr indent="0" marL="0">
+              <a:buNone/>
+            </a:pPr>
+            <a:r>
+              <a:rPr lang="en-US" sz="1050" b="1" dirty="0">
+                <a:solidFill>
+                  <a:srgbClr val="F8FAFC"/>
+                </a:solidFill>
+                <a:latin typeface="Arial" pitchFamily="34" charset="0"/>
+                <a:ea typeface="Arial" pitchFamily="34" charset="-122"/>
+                <a:cs typeface="Arial" pitchFamily="34" charset="-120"/>
+              </a:rPr>
+              <a:t>👤 Jayaditya De</a:t>
+            </a:r>
+            <a:endParaRPr lang="en-US" sz="1050" dirty="0"/>
+          </a:p>
+        </p:txBody>
+      </p:sp>
+      <p:sp>
+        <p:nvSpPr>
+          <p:cNvPr id="22" name="Text 19"/>
+          <p:cNvSpPr/>
+          <p:nvPr/>
+        </p:nvSpPr>
+        <p:spPr>
+          <a:xfrm>
+            <a:off x="8961120" y="4434840"/>
+            <a:ext cx="2331720" cy="411480"/>
+          </a:xfrm>
+          <a:prstGeom prst="rect">
+            <a:avLst/>
+          </a:prstGeom>
+          <a:noFill/>
+          <a:ln/>
+        </p:spPr>
+        <p:txBody>
+          <a:bodyPr wrap="square" rtlCol="0" anchor="ctr"/>
+          <a:lstStyle/>
+          <a:p>
+            <a:pPr indent="0" marL="0">
+              <a:buNone/>
+            </a:pPr>
+            <a:r>
+              <a:rPr lang="en-US" sz="900" b="1" dirty="0">
+                <a:solidFill>
+                  <a:srgbClr val="C084FC"/>
+                </a:solidFill>
+                <a:latin typeface="Consolas" pitchFamily="34" charset="0"/>
+                <a:ea typeface="Consolas" pitchFamily="34" charset="-122"/>
+                <a:cs typeface="Consolas" pitchFamily="34" charset="-120"/>
+              </a:rPr>
+              <a:t>Linguistic &amp; NLP Researcher</a:t>
+            </a:r>
+            <a:endParaRPr lang="en-US" sz="900" dirty="0"/>
+          </a:p>
+        </p:txBody>
+      </p:sp>
+      <p:sp>
+        <p:nvSpPr>
+          <p:cNvPr id="23" name="Text 20"/>
+          <p:cNvSpPr/>
+          <p:nvPr/>
+        </p:nvSpPr>
+        <p:spPr>
+          <a:xfrm>
+            <a:off x="8961120" y="4892040"/>
+            <a:ext cx="2331720" cy="1005840"/>
+          </a:xfrm>
+          <a:prstGeom prst="rect">
+            <a:avLst/>
+          </a:prstGeom>
+          <a:noFill/>
+          <a:ln/>
+        </p:spPr>
+        <p:txBody>
+          <a:bodyPr wrap="square" rtlCol="0" anchor="ctr"/>
+          <a:lstStyle/>
+          <a:p>
+            <a:pPr indent="0" marL="0">
+              <a:buNone/>
+            </a:pPr>
+            <a:r>
+              <a:rPr lang="en-US" sz="950" dirty="0">
+                <a:solidFill>
+                  <a:srgbClr val="94A3B8"/>
+                </a:solidFill>
+                <a:latin typeface="Calibri" pitchFamily="34" charset="0"/>
+                <a:ea typeface="Calibri" pitchFamily="34" charset="-122"/>
+                <a:cs typeface="Calibri" pitchFamily="34" charset="-120"/>
+              </a:rPr>
+              <a:t>Vernacular Lexicon &amp; Deobfuscation</a:t>
+            </a:r>
+            <a:endParaRPr lang="en-US" sz="950" dirty="0"/>
           </a:p>
         </p:txBody>
       </p:sp>
@@ -2162,9 +2330,33 @@
           <a:chExt cx="0" cy="0"/>
         </a:xfrm>
       </p:grpSpPr>
-      <p:sp>
-        <p:nvSpPr>
-          <p:cNvPr id="2" name="Text 0"/>
+      <p:pic>
+        <p:nvPicPr>
+          <p:cNvPr id="2" name="Image 0" descr="D:\hackathon_elicit_acm\public\acm-logo.png">    </p:cNvPr>
+          <p:cNvPicPr>
+            <a:picLocks noChangeAspect="1"/>
+          </p:cNvPicPr>
+          <p:nvPr/>
+        </p:nvPicPr>
+        <p:blipFill>
+          <a:blip r:embed="rId1"/>
+          <a:stretch>
+            <a:fillRect/>
+          </a:stretch>
+        </p:blipFill>
+        <p:spPr>
+          <a:xfrm>
+            <a:off x="731520" y="320040"/>
+            <a:ext cx="411480" cy="411480"/>
+          </a:xfrm>
+          <a:prstGeom prst="rect">
+            <a:avLst/>
+          </a:prstGeom>
+        </p:spPr>
+      </p:pic>
+      <p:sp>
+        <p:nvSpPr>
+          <p:cNvPr id="3" name="Text 0"/>
           <p:cNvSpPr/>
           <p:nvPr/>
         </p:nvSpPr>
@@ -2203,7 +2395,7 @@
       </p:sp>
       <p:sp>
         <p:nvSpPr>
-          <p:cNvPr id="3" name="Text 1"/>
+          <p:cNvPr id="4" name="Text 1"/>
           <p:cNvSpPr/>
           <p:nvPr/>
         </p:nvSpPr>
@@ -2242,7 +2434,7 @@
       </p:sp>
       <p:sp>
         <p:nvSpPr>
-          <p:cNvPr id="4" name="Shape 2"/>
+          <p:cNvPr id="5" name="Shape 2"/>
           <p:cNvSpPr/>
           <p:nvPr/>
         </p:nvSpPr>
@@ -2269,7 +2461,7 @@
       </p:sp>
       <p:sp>
         <p:nvSpPr>
-          <p:cNvPr id="5" name="Text 3"/>
+          <p:cNvPr id="6" name="Text 3"/>
           <p:cNvSpPr/>
           <p:nvPr/>
         </p:nvSpPr>
@@ -2308,7 +2500,7 @@
       </p:sp>
       <p:sp>
         <p:nvSpPr>
-          <p:cNvPr id="6" name="Text 4"/>
+          <p:cNvPr id="7" name="Text 4"/>
           <p:cNvSpPr/>
           <p:nvPr/>
         </p:nvSpPr>
@@ -2347,7 +2539,7 @@
       </p:sp>
       <p:sp>
         <p:nvSpPr>
-          <p:cNvPr id="7" name="Shape 5"/>
+          <p:cNvPr id="8" name="Shape 5"/>
           <p:cNvSpPr/>
           <p:nvPr/>
         </p:nvSpPr>
@@ -2374,7 +2566,7 @@
       </p:sp>
       <p:sp>
         <p:nvSpPr>
-          <p:cNvPr id="8" name="Text 6"/>
+          <p:cNvPr id="9" name="Text 6"/>
           <p:cNvSpPr/>
           <p:nvPr/>
         </p:nvSpPr>
@@ -2413,7 +2605,7 @@
       </p:sp>
       <p:sp>
         <p:nvSpPr>
-          <p:cNvPr id="9" name="Text 7"/>
+          <p:cNvPr id="10" name="Text 7"/>
           <p:cNvSpPr/>
           <p:nvPr/>
         </p:nvSpPr>
@@ -2452,7 +2644,7 @@
       </p:sp>
       <p:sp>
         <p:nvSpPr>
-          <p:cNvPr id="10" name="Shape 8"/>
+          <p:cNvPr id="11" name="Shape 8"/>
           <p:cNvSpPr/>
           <p:nvPr/>
         </p:nvSpPr>
@@ -2479,7 +2671,7 @@
       </p:sp>
       <p:sp>
         <p:nvSpPr>
-          <p:cNvPr id="11" name="Text 9"/>
+          <p:cNvPr id="12" name="Text 9"/>
           <p:cNvSpPr/>
           <p:nvPr/>
         </p:nvSpPr>
@@ -2518,7 +2710,7 @@
       </p:sp>
       <p:sp>
         <p:nvSpPr>
-          <p:cNvPr id="12" name="Text 10"/>
+          <p:cNvPr id="13" name="Text 10"/>
           <p:cNvSpPr/>
           <p:nvPr/>
         </p:nvSpPr>
@@ -2557,7 +2749,7 @@
       </p:sp>
       <p:sp>
         <p:nvSpPr>
-          <p:cNvPr id="13" name="Shape 11"/>
+          <p:cNvPr id="14" name="Shape 11"/>
           <p:cNvSpPr/>
           <p:nvPr/>
         </p:nvSpPr>
@@ -2584,7 +2776,7 @@
       </p:sp>
       <p:sp>
         <p:nvSpPr>
-          <p:cNvPr id="14" name="Text 12"/>
+          <p:cNvPr id="15" name="Text 12"/>
           <p:cNvSpPr/>
           <p:nvPr/>
         </p:nvSpPr>
@@ -2623,7 +2815,7 @@
       </p:sp>
       <p:sp>
         <p:nvSpPr>
-          <p:cNvPr id="15" name="Text 13"/>
+          <p:cNvPr id="16" name="Text 13"/>
           <p:cNvSpPr/>
           <p:nvPr/>
         </p:nvSpPr>
@@ -2759,7 +2951,7 @@
       </p:sp>
       <p:sp>
         <p:nvSpPr>
-          <p:cNvPr id="16" name="Shape 14"/>
+          <p:cNvPr id="17" name="Shape 14"/>
           <p:cNvSpPr/>
           <p:nvPr/>
         </p:nvSpPr>
@@ -2786,7 +2978,7 @@
       </p:sp>
       <p:sp>
         <p:nvSpPr>
-          <p:cNvPr id="17" name="Text 15"/>
+          <p:cNvPr id="18" name="Text 15"/>
           <p:cNvSpPr/>
           <p:nvPr/>
         </p:nvSpPr>
@@ -2825,7 +3017,7 @@
       </p:sp>
       <p:sp>
         <p:nvSpPr>
-          <p:cNvPr id="18" name="Text 16"/>
+          <p:cNvPr id="19" name="Text 16"/>
           <p:cNvSpPr/>
           <p:nvPr/>
         </p:nvSpPr>
@@ -2963,9 +3155,33 @@
           <a:chExt cx="0" cy="0"/>
         </a:xfrm>
       </p:grpSpPr>
-      <p:sp>
-        <p:nvSpPr>
-          <p:cNvPr id="2" name="Text 0"/>
+      <p:pic>
+        <p:nvPicPr>
+          <p:cNvPr id="2" name="Image 0" descr="D:\hackathon_elicit_acm\public\acm-logo.png">    </p:cNvPr>
+          <p:cNvPicPr>
+            <a:picLocks noChangeAspect="1"/>
+          </p:cNvPicPr>
+          <p:nvPr/>
+        </p:nvPicPr>
+        <p:blipFill>
+          <a:blip r:embed="rId1"/>
+          <a:stretch>
+            <a:fillRect/>
+          </a:stretch>
+        </p:blipFill>
+        <p:spPr>
+          <a:xfrm>
+            <a:off x="731520" y="320040"/>
+            <a:ext cx="411480" cy="411480"/>
+          </a:xfrm>
+          <a:prstGeom prst="rect">
+            <a:avLst/>
+          </a:prstGeom>
+        </p:spPr>
+      </p:pic>
+      <p:sp>
+        <p:nvSpPr>
+          <p:cNvPr id="3" name="Text 0"/>
           <p:cNvSpPr/>
           <p:nvPr/>
         </p:nvSpPr>
@@ -3004,7 +3220,7 @@
       </p:sp>
       <p:sp>
         <p:nvSpPr>
-          <p:cNvPr id="3" name="Text 1"/>
+          <p:cNvPr id="4" name="Text 1"/>
           <p:cNvSpPr/>
           <p:nvPr/>
         </p:nvSpPr>
@@ -4491,7 +4707,7 @@
       </p:graphicFrame>
       <p:sp>
         <p:nvSpPr>
-          <p:cNvPr id="5" name="Shape 2"/>
+          <p:cNvPr id="6" name="Shape 2"/>
           <p:cNvSpPr/>
           <p:nvPr/>
         </p:nvSpPr>
@@ -4518,7 +4734,7 @@
       </p:sp>
       <p:sp>
         <p:nvSpPr>
-          <p:cNvPr id="6" name="Text 3"/>
+          <p:cNvPr id="7" name="Text 3"/>
           <p:cNvSpPr/>
           <p:nvPr/>
         </p:nvSpPr>
@@ -4557,7 +4773,7 @@
       </p:sp>
       <p:sp>
         <p:nvSpPr>
-          <p:cNvPr id="7" name="Text 4"/>
+          <p:cNvPr id="8" name="Text 4"/>
           <p:cNvSpPr/>
           <p:nvPr/>
         </p:nvSpPr>
@@ -4660,9 +4876,33 @@
           <a:chExt cx="0" cy="0"/>
         </a:xfrm>
       </p:grpSpPr>
-      <p:sp>
-        <p:nvSpPr>
-          <p:cNvPr id="2" name="Text 0"/>
+      <p:pic>
+        <p:nvPicPr>
+          <p:cNvPr id="2" name="Image 0" descr="D:\hackathon_elicit_acm\public\acm-logo.png">    </p:cNvPr>
+          <p:cNvPicPr>
+            <a:picLocks noChangeAspect="1"/>
+          </p:cNvPicPr>
+          <p:nvPr/>
+        </p:nvPicPr>
+        <p:blipFill>
+          <a:blip r:embed="rId1"/>
+          <a:stretch>
+            <a:fillRect/>
+          </a:stretch>
+        </p:blipFill>
+        <p:spPr>
+          <a:xfrm>
+            <a:off x="731520" y="320040"/>
+            <a:ext cx="411480" cy="411480"/>
+          </a:xfrm>
+          <a:prstGeom prst="rect">
+            <a:avLst/>
+          </a:prstGeom>
+        </p:spPr>
+      </p:pic>
+      <p:sp>
+        <p:nvSpPr>
+          <p:cNvPr id="3" name="Text 0"/>
           <p:cNvSpPr/>
           <p:nvPr/>
         </p:nvSpPr>
@@ -4701,7 +4941,7 @@
       </p:sp>
       <p:sp>
         <p:nvSpPr>
-          <p:cNvPr id="3" name="Text 1"/>
+          <p:cNvPr id="4" name="Text 1"/>
           <p:cNvSpPr/>
           <p:nvPr/>
         </p:nvSpPr>
@@ -4740,7 +4980,7 @@
       </p:sp>
       <p:sp>
         <p:nvSpPr>
-          <p:cNvPr id="4" name="Shape 2"/>
+          <p:cNvPr id="5" name="Shape 2"/>
           <p:cNvSpPr/>
           <p:nvPr/>
         </p:nvSpPr>
@@ -4767,7 +5007,7 @@
       </p:sp>
       <p:sp>
         <p:nvSpPr>
-          <p:cNvPr id="5" name="Text 3"/>
+          <p:cNvPr id="6" name="Text 3"/>
           <p:cNvSpPr/>
           <p:nvPr/>
         </p:nvSpPr>
@@ -4806,7 +5046,7 @@
       </p:sp>
       <p:sp>
         <p:nvSpPr>
-          <p:cNvPr id="6" name="Text 4"/>
+          <p:cNvPr id="7" name="Text 4"/>
           <p:cNvSpPr/>
           <p:nvPr/>
         </p:nvSpPr>
@@ -4845,7 +5085,7 @@
       </p:sp>
       <p:sp>
         <p:nvSpPr>
-          <p:cNvPr id="7" name="Text 5"/>
+          <p:cNvPr id="8" name="Text 5"/>
           <p:cNvSpPr/>
           <p:nvPr/>
         </p:nvSpPr>
@@ -4884,7 +5124,7 @@
       </p:sp>
       <p:sp>
         <p:nvSpPr>
-          <p:cNvPr id="8" name="Shape 6"/>
+          <p:cNvPr id="9" name="Shape 6"/>
           <p:cNvSpPr/>
           <p:nvPr/>
         </p:nvSpPr>
@@ -4911,7 +5151,7 @@
       </p:sp>
       <p:sp>
         <p:nvSpPr>
-          <p:cNvPr id="9" name="Text 7"/>
+          <p:cNvPr id="10" name="Text 7"/>
           <p:cNvSpPr/>
           <p:nvPr/>
         </p:nvSpPr>
@@ -4950,7 +5190,7 @@
       </p:sp>
       <p:sp>
         <p:nvSpPr>
-          <p:cNvPr id="10" name="Text 8"/>
+          <p:cNvPr id="11" name="Text 8"/>
           <p:cNvSpPr/>
           <p:nvPr/>
         </p:nvSpPr>
@@ -4989,7 +5229,7 @@
       </p:sp>
       <p:sp>
         <p:nvSpPr>
-          <p:cNvPr id="11" name="Text 9"/>
+          <p:cNvPr id="12" name="Text 9"/>
           <p:cNvSpPr/>
           <p:nvPr/>
         </p:nvSpPr>
@@ -5028,7 +5268,7 @@
       </p:sp>
       <p:sp>
         <p:nvSpPr>
-          <p:cNvPr id="12" name="Shape 10"/>
+          <p:cNvPr id="13" name="Shape 10"/>
           <p:cNvSpPr/>
           <p:nvPr/>
         </p:nvSpPr>
@@ -5055,7 +5295,7 @@
       </p:sp>
       <p:sp>
         <p:nvSpPr>
-          <p:cNvPr id="13" name="Text 11"/>
+          <p:cNvPr id="14" name="Text 11"/>
           <p:cNvSpPr/>
           <p:nvPr/>
         </p:nvSpPr>
@@ -5094,7 +5334,7 @@
       </p:sp>
       <p:sp>
         <p:nvSpPr>
-          <p:cNvPr id="14" name="Text 12"/>
+          <p:cNvPr id="15" name="Text 12"/>
           <p:cNvSpPr/>
           <p:nvPr/>
         </p:nvSpPr>
@@ -5133,7 +5373,7 @@
       </p:sp>
       <p:sp>
         <p:nvSpPr>
-          <p:cNvPr id="15" name="Text 13"/>
+          <p:cNvPr id="16" name="Text 13"/>
           <p:cNvSpPr/>
           <p:nvPr/>
         </p:nvSpPr>
@@ -5172,7 +5412,7 @@
       </p:sp>
       <p:sp>
         <p:nvSpPr>
-          <p:cNvPr id="16" name="Shape 14"/>
+          <p:cNvPr id="17" name="Shape 14"/>
           <p:cNvSpPr/>
           <p:nvPr/>
         </p:nvSpPr>
@@ -5199,7 +5439,7 @@
       </p:sp>
       <p:sp>
         <p:nvSpPr>
-          <p:cNvPr id="17" name="Text 15"/>
+          <p:cNvPr id="18" name="Text 15"/>
           <p:cNvSpPr/>
           <p:nvPr/>
         </p:nvSpPr>
@@ -5238,7 +5478,7 @@
       </p:sp>
       <p:sp>
         <p:nvSpPr>
-          <p:cNvPr id="18" name="Text 16"/>
+          <p:cNvPr id="19" name="Text 16"/>
           <p:cNvSpPr/>
           <p:nvPr/>
         </p:nvSpPr>
@@ -5277,7 +5517,7 @@
       </p:sp>
       <p:sp>
         <p:nvSpPr>
-          <p:cNvPr id="19" name="Text 17"/>
+          <p:cNvPr id="20" name="Text 17"/>
           <p:cNvSpPr/>
           <p:nvPr/>
         </p:nvSpPr>
@@ -5346,9 +5586,33 @@
           <a:chExt cx="0" cy="0"/>
         </a:xfrm>
       </p:grpSpPr>
-      <p:sp>
-        <p:nvSpPr>
-          <p:cNvPr id="2" name="Text 0"/>
+      <p:pic>
+        <p:nvPicPr>
+          <p:cNvPr id="2" name="Image 0" descr="D:\hackathon_elicit_acm\public\acm-logo.png">    </p:cNvPr>
+          <p:cNvPicPr>
+            <a:picLocks noChangeAspect="1"/>
+          </p:cNvPicPr>
+          <p:nvPr/>
+        </p:nvPicPr>
+        <p:blipFill>
+          <a:blip r:embed="rId1"/>
+          <a:stretch>
+            <a:fillRect/>
+          </a:stretch>
+        </p:blipFill>
+        <p:spPr>
+          <a:xfrm>
+            <a:off x="731520" y="320040"/>
+            <a:ext cx="411480" cy="411480"/>
+          </a:xfrm>
+          <a:prstGeom prst="rect">
+            <a:avLst/>
+          </a:prstGeom>
+        </p:spPr>
+      </p:pic>
+      <p:sp>
+        <p:nvSpPr>
+          <p:cNvPr id="3" name="Text 0"/>
           <p:cNvSpPr/>
           <p:nvPr/>
         </p:nvSpPr>
@@ -5387,7 +5651,7 @@
       </p:sp>
       <p:sp>
         <p:nvSpPr>
-          <p:cNvPr id="3" name="Text 1"/>
+          <p:cNvPr id="4" name="Text 1"/>
           <p:cNvSpPr/>
           <p:nvPr/>
         </p:nvSpPr>
@@ -5426,7 +5690,7 @@
       </p:sp>
       <p:sp>
         <p:nvSpPr>
-          <p:cNvPr id="4" name="Shape 2"/>
+          <p:cNvPr id="5" name="Shape 2"/>
           <p:cNvSpPr/>
           <p:nvPr/>
         </p:nvSpPr>
@@ -5453,7 +5717,7 @@
       </p:sp>
       <p:sp>
         <p:nvSpPr>
-          <p:cNvPr id="5" name="Text 3"/>
+          <p:cNvPr id="6" name="Text 3"/>
           <p:cNvSpPr/>
           <p:nvPr/>
         </p:nvSpPr>
@@ -5492,7 +5756,7 @@
       </p:sp>
       <p:sp>
         <p:nvSpPr>
-          <p:cNvPr id="6" name="Text 4"/>
+          <p:cNvPr id="7" name="Text 4"/>
           <p:cNvSpPr/>
           <p:nvPr/>
         </p:nvSpPr>
@@ -5531,7 +5795,7 @@
       </p:sp>
       <p:sp>
         <p:nvSpPr>
-          <p:cNvPr id="7" name="Text 5"/>
+          <p:cNvPr id="8" name="Text 5"/>
           <p:cNvSpPr/>
           <p:nvPr/>
         </p:nvSpPr>
@@ -5570,7 +5834,7 @@
       </p:sp>
       <p:sp>
         <p:nvSpPr>
-          <p:cNvPr id="8" name="Shape 6"/>
+          <p:cNvPr id="9" name="Shape 6"/>
           <p:cNvSpPr/>
           <p:nvPr/>
         </p:nvSpPr>
@@ -5597,7 +5861,7 @@
       </p:sp>
       <p:sp>
         <p:nvSpPr>
-          <p:cNvPr id="9" name="Text 7"/>
+          <p:cNvPr id="10" name="Text 7"/>
           <p:cNvSpPr/>
           <p:nvPr/>
         </p:nvSpPr>
@@ -5636,7 +5900,7 @@
       </p:sp>
       <p:sp>
         <p:nvSpPr>
-          <p:cNvPr id="10" name="Text 8"/>
+          <p:cNvPr id="11" name="Text 8"/>
           <p:cNvSpPr/>
           <p:nvPr/>
         </p:nvSpPr>
@@ -5675,7 +5939,7 @@
       </p:sp>
       <p:sp>
         <p:nvSpPr>
-          <p:cNvPr id="11" name="Text 9"/>
+          <p:cNvPr id="12" name="Text 9"/>
           <p:cNvSpPr/>
           <p:nvPr/>
         </p:nvSpPr>
@@ -5714,7 +5978,7 @@
       </p:sp>
       <p:sp>
         <p:nvSpPr>
-          <p:cNvPr id="12" name="Shape 10"/>
+          <p:cNvPr id="13" name="Shape 10"/>
           <p:cNvSpPr/>
           <p:nvPr/>
         </p:nvSpPr>
@@ -5741,7 +6005,7 @@
       </p:sp>
       <p:sp>
         <p:nvSpPr>
-          <p:cNvPr id="13" name="Text 11"/>
+          <p:cNvPr id="14" name="Text 11"/>
           <p:cNvSpPr/>
           <p:nvPr/>
         </p:nvSpPr>
@@ -5780,7 +6044,7 @@
       </p:sp>
       <p:sp>
         <p:nvSpPr>
-          <p:cNvPr id="14" name="Text 12"/>
+          <p:cNvPr id="15" name="Text 12"/>
           <p:cNvSpPr/>
           <p:nvPr/>
         </p:nvSpPr>
@@ -5819,7 +6083,7 @@
       </p:sp>
       <p:sp>
         <p:nvSpPr>
-          <p:cNvPr id="15" name="Text 13"/>
+          <p:cNvPr id="16" name="Text 13"/>
           <p:cNvSpPr/>
           <p:nvPr/>
         </p:nvSpPr>
@@ -5858,7 +6122,7 @@
       </p:sp>
       <p:sp>
         <p:nvSpPr>
-          <p:cNvPr id="16" name="Shape 14"/>
+          <p:cNvPr id="17" name="Shape 14"/>
           <p:cNvSpPr/>
           <p:nvPr/>
         </p:nvSpPr>
@@ -5885,7 +6149,7 @@
       </p:sp>
       <p:sp>
         <p:nvSpPr>
-          <p:cNvPr id="17" name="Text 15"/>
+          <p:cNvPr id="18" name="Text 15"/>
           <p:cNvSpPr/>
           <p:nvPr/>
         </p:nvSpPr>
@@ -5924,7 +6188,7 @@
       </p:sp>
       <p:sp>
         <p:nvSpPr>
-          <p:cNvPr id="18" name="Text 16"/>
+          <p:cNvPr id="19" name="Text 16"/>
           <p:cNvSpPr/>
           <p:nvPr/>
         </p:nvSpPr>
@@ -5963,7 +6227,7 @@
       </p:sp>
       <p:sp>
         <p:nvSpPr>
-          <p:cNvPr id="19" name="Text 17"/>
+          <p:cNvPr id="20" name="Text 17"/>
           <p:cNvSpPr/>
           <p:nvPr/>
         </p:nvSpPr>
@@ -6002,7 +6266,7 @@
       </p:sp>
       <p:sp>
         <p:nvSpPr>
-          <p:cNvPr id="20" name="Shape 18"/>
+          <p:cNvPr id="21" name="Shape 18"/>
           <p:cNvSpPr/>
           <p:nvPr/>
         </p:nvSpPr>
@@ -6029,7 +6293,7 @@
       </p:sp>
       <p:sp>
         <p:nvSpPr>
-          <p:cNvPr id="21" name="Text 19"/>
+          <p:cNvPr id="22" name="Text 19"/>
           <p:cNvSpPr/>
           <p:nvPr/>
         </p:nvSpPr>
@@ -6068,7 +6332,7 @@
       </p:sp>
       <p:sp>
         <p:nvSpPr>
-          <p:cNvPr id="22" name="Text 20"/>
+          <p:cNvPr id="23" name="Text 20"/>
           <p:cNvSpPr/>
           <p:nvPr/>
         </p:nvSpPr>
@@ -6107,7 +6371,7 @@
       </p:sp>
       <p:sp>
         <p:nvSpPr>
-          <p:cNvPr id="23" name="Text 21"/>
+          <p:cNvPr id="24" name="Text 21"/>
           <p:cNvSpPr/>
           <p:nvPr/>
         </p:nvSpPr>
@@ -6146,7 +6410,7 @@
       </p:sp>
       <p:sp>
         <p:nvSpPr>
-          <p:cNvPr id="24" name="Shape 22"/>
+          <p:cNvPr id="25" name="Shape 22"/>
           <p:cNvSpPr/>
           <p:nvPr/>
         </p:nvSpPr>
@@ -6173,7 +6437,7 @@
       </p:sp>
       <p:sp>
         <p:nvSpPr>
-          <p:cNvPr id="25" name="Text 23"/>
+          <p:cNvPr id="26" name="Text 23"/>
           <p:cNvSpPr/>
           <p:nvPr/>
         </p:nvSpPr>
@@ -6212,7 +6476,7 @@
       </p:sp>
       <p:sp>
         <p:nvSpPr>
-          <p:cNvPr id="26" name="Text 24"/>
+          <p:cNvPr id="27" name="Text 24"/>
           <p:cNvSpPr/>
           <p:nvPr/>
         </p:nvSpPr>
@@ -6332,9 +6596,33 @@
           <a:chExt cx="0" cy="0"/>
         </a:xfrm>
       </p:grpSpPr>
-      <p:sp>
-        <p:nvSpPr>
-          <p:cNvPr id="2" name="Text 0"/>
+      <p:pic>
+        <p:nvPicPr>
+          <p:cNvPr id="2" name="Image 0" descr="D:\hackathon_elicit_acm\public\acm-logo.png">    </p:cNvPr>
+          <p:cNvPicPr>
+            <a:picLocks noChangeAspect="1"/>
+          </p:cNvPicPr>
+          <p:nvPr/>
+        </p:nvPicPr>
+        <p:blipFill>
+          <a:blip r:embed="rId1"/>
+          <a:stretch>
+            <a:fillRect/>
+          </a:stretch>
+        </p:blipFill>
+        <p:spPr>
+          <a:xfrm>
+            <a:off x="731520" y="320040"/>
+            <a:ext cx="411480" cy="411480"/>
+          </a:xfrm>
+          <a:prstGeom prst="rect">
+            <a:avLst/>
+          </a:prstGeom>
+        </p:spPr>
+      </p:pic>
+      <p:sp>
+        <p:nvSpPr>
+          <p:cNvPr id="3" name="Text 0"/>
           <p:cNvSpPr/>
           <p:nvPr/>
         </p:nvSpPr>
@@ -6373,7 +6661,7 @@
       </p:sp>
       <p:sp>
         <p:nvSpPr>
-          <p:cNvPr id="3" name="Text 1"/>
+          <p:cNvPr id="4" name="Text 1"/>
           <p:cNvSpPr/>
           <p:nvPr/>
         </p:nvSpPr>
@@ -8247,7 +8535,7 @@
       </p:graphicFrame>
       <p:sp>
         <p:nvSpPr>
-          <p:cNvPr id="5" name="Shape 2"/>
+          <p:cNvPr id="6" name="Shape 2"/>
           <p:cNvSpPr/>
           <p:nvPr/>
         </p:nvSpPr>
@@ -8274,7 +8562,7 @@
       </p:sp>
       <p:sp>
         <p:nvSpPr>
-          <p:cNvPr id="6" name="Text 3"/>
+          <p:cNvPr id="7" name="Text 3"/>
           <p:cNvSpPr/>
           <p:nvPr/>
         </p:nvSpPr>
@@ -8313,7 +8601,7 @@
       </p:sp>
       <p:sp>
         <p:nvSpPr>
-          <p:cNvPr id="7" name="Text 4"/>
+          <p:cNvPr id="8" name="Text 4"/>
           <p:cNvSpPr/>
           <p:nvPr/>
         </p:nvSpPr>
@@ -8416,9 +8704,33 @@
           <a:chExt cx="0" cy="0"/>
         </a:xfrm>
       </p:grpSpPr>
-      <p:sp>
-        <p:nvSpPr>
-          <p:cNvPr id="2" name="Text 0"/>
+      <p:pic>
+        <p:nvPicPr>
+          <p:cNvPr id="2" name="Image 0" descr="D:\hackathon_elicit_acm\public\acm-logo.png">    </p:cNvPr>
+          <p:cNvPicPr>
+            <a:picLocks noChangeAspect="1"/>
+          </p:cNvPicPr>
+          <p:nvPr/>
+        </p:nvPicPr>
+        <p:blipFill>
+          <a:blip r:embed="rId1"/>
+          <a:stretch>
+            <a:fillRect/>
+          </a:stretch>
+        </p:blipFill>
+        <p:spPr>
+          <a:xfrm>
+            <a:off x="731520" y="320040"/>
+            <a:ext cx="411480" cy="411480"/>
+          </a:xfrm>
+          <a:prstGeom prst="rect">
+            <a:avLst/>
+          </a:prstGeom>
+        </p:spPr>
+      </p:pic>
+      <p:sp>
+        <p:nvSpPr>
+          <p:cNvPr id="3" name="Text 0"/>
           <p:cNvSpPr/>
           <p:nvPr/>
         </p:nvSpPr>
@@ -8457,7 +8769,7 @@
       </p:sp>
       <p:sp>
         <p:nvSpPr>
-          <p:cNvPr id="3" name="Text 1"/>
+          <p:cNvPr id="4" name="Text 1"/>
           <p:cNvSpPr/>
           <p:nvPr/>
         </p:nvSpPr>
@@ -8496,7 +8808,7 @@
       </p:sp>
       <p:sp>
         <p:nvSpPr>
-          <p:cNvPr id="4" name="Shape 2"/>
+          <p:cNvPr id="5" name="Shape 2"/>
           <p:cNvSpPr/>
           <p:nvPr/>
         </p:nvSpPr>
@@ -8523,7 +8835,7 @@
       </p:sp>
       <p:sp>
         <p:nvSpPr>
-          <p:cNvPr id="5" name="Text 3"/>
+          <p:cNvPr id="6" name="Text 3"/>
           <p:cNvSpPr/>
           <p:nvPr/>
         </p:nvSpPr>
@@ -8562,7 +8874,7 @@
       </p:sp>
       <p:sp>
         <p:nvSpPr>
-          <p:cNvPr id="6" name="Text 4"/>
+          <p:cNvPr id="7" name="Text 4"/>
           <p:cNvSpPr/>
           <p:nvPr/>
         </p:nvSpPr>
@@ -8670,7 +8982,7 @@
       </p:sp>
       <p:sp>
         <p:nvSpPr>
-          <p:cNvPr id="7" name="Shape 5"/>
+          <p:cNvPr id="8" name="Shape 5"/>
           <p:cNvSpPr/>
           <p:nvPr/>
         </p:nvSpPr>
@@ -8697,7 +9009,7 @@
       </p:sp>
       <p:sp>
         <p:nvSpPr>
-          <p:cNvPr id="8" name="Text 6"/>
+          <p:cNvPr id="9" name="Text 6"/>
           <p:cNvSpPr/>
           <p:nvPr/>
         </p:nvSpPr>
@@ -8736,7 +9048,7 @@
       </p:sp>
       <p:sp>
         <p:nvSpPr>
-          <p:cNvPr id="9" name="Text 7"/>
+          <p:cNvPr id="10" name="Text 7"/>
           <p:cNvSpPr/>
           <p:nvPr/>
         </p:nvSpPr>
@@ -8874,9 +9186,33 @@
           <a:chExt cx="0" cy="0"/>
         </a:xfrm>
       </p:grpSpPr>
-      <p:sp>
-        <p:nvSpPr>
-          <p:cNvPr id="2" name="Text 0"/>
+      <p:pic>
+        <p:nvPicPr>
+          <p:cNvPr id="2" name="Image 0" descr="D:\hackathon_elicit_acm\public\acm-logo.png">    </p:cNvPr>
+          <p:cNvPicPr>
+            <a:picLocks noChangeAspect="1"/>
+          </p:cNvPicPr>
+          <p:nvPr/>
+        </p:nvPicPr>
+        <p:blipFill>
+          <a:blip r:embed="rId1"/>
+          <a:stretch>
+            <a:fillRect/>
+          </a:stretch>
+        </p:blipFill>
+        <p:spPr>
+          <a:xfrm>
+            <a:off x="731520" y="320040"/>
+            <a:ext cx="411480" cy="411480"/>
+          </a:xfrm>
+          <a:prstGeom prst="rect">
+            <a:avLst/>
+          </a:prstGeom>
+        </p:spPr>
+      </p:pic>
+      <p:sp>
+        <p:nvSpPr>
+          <p:cNvPr id="3" name="Text 0"/>
           <p:cNvSpPr/>
           <p:nvPr/>
         </p:nvSpPr>
@@ -8915,7 +9251,7 @@
       </p:sp>
       <p:sp>
         <p:nvSpPr>
-          <p:cNvPr id="3" name="Text 1"/>
+          <p:cNvPr id="4" name="Text 1"/>
           <p:cNvSpPr/>
           <p:nvPr/>
         </p:nvSpPr>
@@ -8954,7 +9290,7 @@
       </p:sp>
       <p:sp>
         <p:nvSpPr>
-          <p:cNvPr id="4" name="Shape 2"/>
+          <p:cNvPr id="5" name="Shape 2"/>
           <p:cNvSpPr/>
           <p:nvPr/>
         </p:nvSpPr>
@@ -8981,7 +9317,7 @@
       </p:sp>
       <p:sp>
         <p:nvSpPr>
-          <p:cNvPr id="5" name="Text 3"/>
+          <p:cNvPr id="6" name="Text 3"/>
           <p:cNvSpPr/>
           <p:nvPr/>
         </p:nvSpPr>
@@ -9020,7 +9356,7 @@
       </p:sp>
       <p:sp>
         <p:nvSpPr>
-          <p:cNvPr id="6" name="Text 4"/>
+          <p:cNvPr id="7" name="Text 4"/>
           <p:cNvSpPr/>
           <p:nvPr/>
         </p:nvSpPr>
@@ -9059,7 +9395,7 @@
       </p:sp>
       <p:sp>
         <p:nvSpPr>
-          <p:cNvPr id="7" name="Shape 5"/>
+          <p:cNvPr id="8" name="Shape 5"/>
           <p:cNvSpPr/>
           <p:nvPr/>
         </p:nvSpPr>
@@ -9086,7 +9422,7 @@
       </p:sp>
       <p:sp>
         <p:nvSpPr>
-          <p:cNvPr id="8" name="Text 6"/>
+          <p:cNvPr id="9" name="Text 6"/>
           <p:cNvSpPr/>
           <p:nvPr/>
         </p:nvSpPr>
@@ -9125,7 +9461,7 @@
       </p:sp>
       <p:sp>
         <p:nvSpPr>
-          <p:cNvPr id="9" name="Text 7"/>
+          <p:cNvPr id="10" name="Text 7"/>
           <p:cNvSpPr/>
           <p:nvPr/>
         </p:nvSpPr>
@@ -9164,7 +9500,7 @@
       </p:sp>
       <p:sp>
         <p:nvSpPr>
-          <p:cNvPr id="10" name="Shape 8"/>
+          <p:cNvPr id="11" name="Shape 8"/>
           <p:cNvSpPr/>
           <p:nvPr/>
         </p:nvSpPr>
@@ -9191,7 +9527,7 @@
       </p:sp>
       <p:sp>
         <p:nvSpPr>
-          <p:cNvPr id="11" name="Text 9"/>
+          <p:cNvPr id="12" name="Text 9"/>
           <p:cNvSpPr/>
           <p:nvPr/>
         </p:nvSpPr>
@@ -9230,7 +9566,7 @@
       </p:sp>
       <p:sp>
         <p:nvSpPr>
-          <p:cNvPr id="12" name="Text 10"/>
+          <p:cNvPr id="13" name="Text 10"/>
           <p:cNvSpPr/>
           <p:nvPr/>
         </p:nvSpPr>
@@ -9269,7 +9605,7 @@
       </p:sp>
       <p:sp>
         <p:nvSpPr>
-          <p:cNvPr id="13" name="Shape 11"/>
+          <p:cNvPr id="14" name="Shape 11"/>
           <p:cNvSpPr/>
           <p:nvPr/>
         </p:nvSpPr>
@@ -9296,7 +9632,7 @@
       </p:sp>
       <p:sp>
         <p:nvSpPr>
-          <p:cNvPr id="14" name="Text 12"/>
+          <p:cNvPr id="15" name="Text 12"/>
           <p:cNvSpPr/>
           <p:nvPr/>
         </p:nvSpPr>
@@ -9335,7 +9671,7 @@
       </p:sp>
       <p:sp>
         <p:nvSpPr>
-          <p:cNvPr id="15" name="Text 13"/>
+          <p:cNvPr id="16" name="Text 13"/>
           <p:cNvSpPr/>
           <p:nvPr/>
         </p:nvSpPr>

</xml_diff>